<commit_message>
Demonstrate historical bias in a held-out model
</commit_message>
<xml_diff>
--- a/job-matching-fairness/facilitator/slides/job_matching_fairness_workshop.pptx
+++ b/job-matching-fairness/facilitator/slides/job_matching_fairness_workshop.pptx
@@ -13220,19 +13220,8 @@
           </a:bodyPr>
           <a:lstStyle/>
           <a:p>
-            <a:pPr algn="l">
-              <a:spcAft>
-                <a:spcPts val="800"/>
-              </a:spcAft>
-              <a:defRPr sz="2800" b="1">
-                <a:solidFill>
-                  <a:srgbClr val="1C314B"/>
-                </a:solidFill>
-                <a:latin typeface="Aptos"/>
-              </a:defRPr>
-            </a:pPr>
-            <a:r>
-              <a:t>A shortlist difference survives a qualification comparison</a:t>
+            <a:r>
+              <a:t>Replaying the past changes who advances</a:t>
             </a:r>
           </a:p>
         </p:txBody>
@@ -13419,19 +13408,8 @@
           </a:bodyPr>
           <a:lstStyle/>
           <a:p>
-            <a:pPr algn="l">
-              <a:spcAft>
-                <a:spcPts val="800"/>
-              </a:spcAft>
-              <a:defRPr sz="1700" b="1">
-                <a:solidFill>
-                  <a:srgbClr val="2B3642"/>
-                </a:solidFill>
-                <a:latin typeface="Aptos"/>
-              </a:defRPr>
-            </a:pPr>
-            <a:r>
-              <a:t>Men</a:t>
+            <a:r>
+              <a:t>Score-only proxy</a:t>
             </a:r>
           </a:p>
         </p:txBody>
@@ -13544,19 +13522,8 @@
           </a:bodyPr>
           <a:lstStyle/>
           <a:p>
-            <a:pPr algn="l">
-              <a:spcAft>
-                <a:spcPts val="800"/>
-              </a:spcAft>
-              <a:defRPr sz="1700" b="1">
-                <a:solidFill>
-                  <a:srgbClr val="37709E"/>
-                </a:solidFill>
-                <a:latin typeface="Aptos"/>
-              </a:defRPr>
-            </a:pPr>
-            <a:r>
-              <a:t>7 / 19 shortlisted</a:t>
+            <a:r>
+              <a:t>Male 5/19; Female 5/31</a:t>
             </a:r>
           </a:p>
         </p:txBody>
@@ -13583,19 +13550,8 @@
           </a:bodyPr>
           <a:lstStyle/>
           <a:p>
-            <a:pPr algn="l">
-              <a:spcAft>
-                <a:spcPts val="800"/>
-              </a:spcAft>
-              <a:defRPr sz="1700" b="1">
-                <a:solidFill>
-                  <a:srgbClr val="2B3642"/>
-                </a:solidFill>
-                <a:latin typeface="Aptos"/>
-              </a:defRPr>
-            </a:pPr>
-            <a:r>
-              <a:t>Women</a:t>
+            <a:r>
+              <a:t>History-trained model</a:t>
             </a:r>
           </a:p>
         </p:txBody>
@@ -13708,19 +13664,8 @@
           </a:bodyPr>
           <a:lstStyle/>
           <a:p>
-            <a:pPr algn="l">
-              <a:spcAft>
-                <a:spcPts val="800"/>
-              </a:spcAft>
-              <a:defRPr sz="1700" b="1">
-                <a:solidFill>
-                  <a:srgbClr val="DE715D"/>
-                </a:solidFill>
-                <a:latin typeface="Aptos"/>
-              </a:defRPr>
-            </a:pPr>
-            <a:r>
-              <a:t>3 / 31 shortlisted</a:t>
+            <a:r>
+              <a:t>Male 10/19; Female 0/31</a:t>
             </a:r>
           </a:p>
         </p:txBody>
@@ -13747,19 +13692,8 @@
           </a:bodyPr>
           <a:lstStyle/>
           <a:p>
-            <a:pPr algn="l">
-              <a:spcAft>
-                <a:spcPts val="800"/>
-              </a:spcAft>
-              <a:defRPr sz="1600" b="0">
-                <a:solidFill>
-                  <a:srgbClr val="677582"/>
-                </a:solidFill>
-                <a:latin typeface="Aptos"/>
-              </a:defRPr>
-            </a:pPr>
-            <a:r>
-              <a:t>The seeded history favors men and Addis Ababa applicants. This is a designed teaching shock—not a real-world finding.</a:t>
+            <a:r>
+              <a:t>Model trained on 13 jobs; JD-01 held out. Historical shortlist was 7/19 males and 3/31 females. Designed synthetic result, not real hiring evidence.</a:t>
             </a:r>
           </a:p>
         </p:txBody>

</xml_diff>

<commit_message>
Simplify historical outcomes investigation
</commit_message>
<xml_diff>
--- a/job-matching-fairness/facilitator/slides/job_matching_fairness_workshop.pptx
+++ b/job-matching-fairness/facilitator/slides/job_matching_fairness_workshop.pptx
@@ -13221,7 +13221,7 @@
           <a:lstStyle/>
           <a:p>
             <a:r>
-              <a:t>Replaying the past changes who advances</a:t>
+              <a:t>Historical shortlisting differs by group</a:t>
             </a:r>
           </a:p>
         </p:txBody>
@@ -13409,7 +13409,7 @@
           <a:lstStyle/>
           <a:p>
             <a:r>
-              <a:t>Score-only proxy</a:t>
+              <a:t>Male applicants</a:t>
             </a:r>
           </a:p>
         </p:txBody>
@@ -13523,7 +13523,7 @@
           <a:lstStyle/>
           <a:p>
             <a:r>
-              <a:t>Male 5/19; Female 5/31</a:t>
+              <a:t>7 / 19 shortlisted</a:t>
             </a:r>
           </a:p>
         </p:txBody>
@@ -13551,7 +13551,7 @@
           <a:lstStyle/>
           <a:p>
             <a:r>
-              <a:t>History-trained model</a:t>
+              <a:t>Female applicants</a:t>
             </a:r>
           </a:p>
         </p:txBody>
@@ -13665,7 +13665,7 @@
           <a:lstStyle/>
           <a:p>
             <a:r>
-              <a:t>Male 10/19; Female 0/31</a:t>
+              <a:t>3 / 31 shortlisted</a:t>
             </a:r>
           </a:p>
         </p:txBody>
@@ -13693,7 +13693,7 @@
           <a:lstStyle/>
           <a:p>
             <a:r>
-              <a:t>Model trained on 13 jobs; JD-01 held out. Historical shortlist was 7/19 males and 3/31 females. Designed synthetic result, not real hiring evidence.</a:t>
+              <a:t>The group effects are deliberately simulated. These counts describe this teaching dataset, not real hiring.</a:t>
             </a:r>
           </a:p>
         </p:txBody>
@@ -13746,19 +13746,8 @@
           </a:bodyPr>
           <a:lstStyle/>
           <a:p>
-            <a:pPr algn="l">
-              <a:spcAft>
-                <a:spcPts val="800"/>
-              </a:spcAft>
-              <a:defRPr sz="1000" b="1">
-                <a:solidFill>
-                  <a:srgbClr val="219187"/>
-                </a:solidFill>
-                <a:latin typeface="Aptos"/>
-              </a:defRPr>
-            </a:pPr>
-            <a:r>
-              <a:t>SELECTIVE LABELS</a:t>
+            <a:r>
+              <a:t>PAUSE - LABEL THE OUTCOMES</a:t>
             </a:r>
           </a:p>
         </p:txBody>
@@ -13988,19 +13977,8 @@
           </a:bodyPr>
           <a:lstStyle/>
           <a:p>
-            <a:pPr algn="ctr">
-              <a:spcAft>
-                <a:spcPts val="800"/>
-              </a:spcAft>
-              <a:defRPr sz="3200" b="1">
-                <a:solidFill>
-                  <a:srgbClr val="37709E"/>
-                </a:solidFill>
-                <a:latin typeface="Aptos"/>
-              </a:defRPr>
-            </a:pPr>
-            <a:r>
-              <a:t>50</a:t>
+            <a:r>
+              <a:t>100</a:t>
             </a:r>
           </a:p>
         </p:txBody>
@@ -14144,17 +14122,6 @@
           </a:bodyPr>
           <a:lstStyle/>
           <a:p>
-            <a:pPr algn="ctr">
-              <a:spcAft>
-                <a:spcPts val="800"/>
-              </a:spcAft>
-              <a:defRPr sz="3200" b="1">
-                <a:solidFill>
-                  <a:srgbClr val="219187"/>
-                </a:solidFill>
-                <a:latin typeface="Aptos"/>
-              </a:defRPr>
-            </a:pPr>
             <a:r>
               <a:t>10</a:t>
             </a:r>
@@ -14183,17 +14150,6 @@
           </a:bodyPr>
           <a:lstStyle/>
           <a:p>
-            <a:pPr algn="ctr">
-              <a:spcAft>
-                <a:spcPts val="800"/>
-              </a:spcAft>
-              <a:defRPr sz="1500" b="1">
-                <a:solidFill>
-                  <a:srgbClr val="1C314B"/>
-                </a:solidFill>
-                <a:latin typeface="Aptos"/>
-              </a:defRPr>
-            </a:pPr>
             <a:r>
               <a:t>Shortlisted</a:t>
             </a:r>
@@ -14300,19 +14256,8 @@
           </a:bodyPr>
           <a:lstStyle/>
           <a:p>
-            <a:pPr algn="ctr">
-              <a:spcAft>
-                <a:spcPts val="800"/>
-              </a:spcAft>
-              <a:defRPr sz="3200" b="1">
-                <a:solidFill>
-                  <a:srgbClr val="DE715D"/>
-                </a:solidFill>
-                <a:latin typeface="Aptos"/>
-              </a:defRPr>
-            </a:pPr>
-            <a:r>
-              <a:t>5</a:t>
+            <a:r>
+              <a:t>1</a:t>
             </a:r>
           </a:p>
         </p:txBody>
@@ -14339,17 +14284,6 @@
           </a:bodyPr>
           <a:lstStyle/>
           <a:p>
-            <a:pPr algn="ctr">
-              <a:spcAft>
-                <a:spcPts val="800"/>
-              </a:spcAft>
-              <a:defRPr sz="1500" b="1">
-                <a:solidFill>
-                  <a:srgbClr val="1C314B"/>
-                </a:solidFill>
-                <a:latin typeface="Aptos"/>
-              </a:defRPr>
-            </a:pPr>
             <a:r>
               <a:t>Hired</a:t>
             </a:r>
@@ -14456,19 +14390,8 @@
           </a:bodyPr>
           <a:lstStyle/>
           <a:p>
-            <a:pPr algn="ctr">
-              <a:spcAft>
-                <a:spcPts val="800"/>
-              </a:spcAft>
-              <a:defRPr sz="3200" b="1">
-                <a:solidFill>
-                  <a:srgbClr val="E2B14B"/>
-                </a:solidFill>
-                <a:latin typeface="Aptos"/>
-              </a:defRPr>
-            </a:pPr>
-            <a:r>
-              <a:t>5</a:t>
+            <a:r>
+              <a:t>?</a:t>
             </a:r>
           </a:p>
         </p:txBody>
@@ -14495,19 +14418,8 @@
           </a:bodyPr>
           <a:lstStyle/>
           <a:p>
-            <a:pPr algn="ctr">
-              <a:spcAft>
-                <a:spcPts val="800"/>
-              </a:spcAft>
-              <a:defRPr sz="1500" b="1">
-                <a:solidFill>
-                  <a:srgbClr val="1C314B"/>
-                </a:solidFill>
-                <a:latin typeface="Aptos"/>
-              </a:defRPr>
-            </a:pPr>
-            <a:r>
-              <a:t>Performance observed</a:t>
+            <a:r>
+              <a:t>Performance recorded?</a:t>
             </a:r>
           </a:p>
         </p:txBody>
@@ -14577,19 +14489,8 @@
           </a:bodyPr>
           <a:lstStyle/>
           <a:p>
-            <a:pPr algn="ctr">
-              <a:spcAft>
-                <a:spcPts val="800"/>
-              </a:spcAft>
-              <a:defRPr sz="1600" b="1">
-                <a:solidFill>
-                  <a:srgbClr val="DE715D"/>
-                </a:solidFill>
-                <a:latin typeface="Aptos"/>
-              </a:defRPr>
-            </a:pPr>
-            <a:r>
-              <a:t>40 not shortlisted → no hiring decision   |   5 shortlisted, not hired   |   45 performance values missing</a:t>
+            <a:r>
+              <a:t>90 not shortlisted: no hire decision  |  9 shortlisted, not hired  |  if performance is assessed only for hires, 99 are unobserved</a:t>
             </a:r>
           </a:p>
         </p:txBody>
@@ -14616,19 +14517,8 @@
           </a:bodyPr>
           <a:lstStyle/>
           <a:p>
-            <a:pPr algn="ctr">
-              <a:spcAft>
-                <a:spcPts val="800"/>
-              </a:spcAft>
-              <a:defRPr sz="1700" b="1">
-                <a:solidFill>
-                  <a:srgbClr val="1C314B"/>
-                </a:solidFill>
-                <a:latin typeface="Aptos"/>
-              </a:defRPr>
-            </a:pPr>
-            <a:r>
-              <a:t>Missing is unknown. Never recode it as zero or “not hired.”</a:t>
+            <a:r>
+              <a:t>Hire count alone does not establish performance. Missing outcomes are unknown, not negative.</a:t>
             </a:r>
           </a:p>
         </p:txBody>

</xml_diff>

<commit_message>
Streamline missing outcome evaluation lesson
</commit_message>
<xml_diff>
--- a/job-matching-fairness/facilitator/slides/job_matching_fairness_workshop.pptx
+++ b/job-matching-fairness/facilitator/slides/job_matching_fairness_workshop.pptx
@@ -13747,7 +13747,7 @@
           <a:lstStyle/>
           <a:p>
             <a:r>
-              <a:t>PAUSE - LABEL THE OUTCOMES</a:t>
+              <a:t>LABEL COVERAGE</a:t>
             </a:r>
           </a:p>
         </p:txBody>
@@ -14490,7 +14490,7 @@
           <a:lstStyle/>
           <a:p>
             <a:r>
-              <a:t>90 not shortlisted: no hire decision  |  9 shortlisted, not hired  |  if performance is assessed only for hires, 99 are unobserved</a:t>
+              <a:t>90 not shortlisted: no hire decision  |  9 shortlisted, not hired  |  up to 99 performance outcomes missing if only the hire is assessed</a:t>
             </a:r>
           </a:p>
         </p:txBody>
@@ -14518,7 +14518,7 @@
           <a:lstStyle/>
           <a:p>
             <a:r>
-              <a:t>Hire count alone does not establish performance. Missing outcomes are unknown, not negative.</a:t>
+              <a:t>Hire status is not performance. Keep unknown outcomes missing.</a:t>
             </a:r>
           </a:p>
         </p:txBody>

</xml_diff>

<commit_message>
Use actual JD-01 outcome counts in Problem 3
</commit_message>
<xml_diff>
--- a/job-matching-fairness/facilitator/slides/job_matching_fairness_workshop.pptx
+++ b/job-matching-fairness/facilitator/slides/job_matching_fairness_workshop.pptx
@@ -13978,7 +13978,7 @@
           <a:lstStyle/>
           <a:p>
             <a:r>
-              <a:t>100</a:t>
+              <a:t>50</a:t>
             </a:r>
           </a:p>
         </p:txBody>
@@ -14257,7 +14257,7 @@
           <a:lstStyle/>
           <a:p>
             <a:r>
-              <a:t>1</a:t>
+              <a:t>5</a:t>
             </a:r>
           </a:p>
         </p:txBody>
@@ -14391,7 +14391,7 @@
           <a:lstStyle/>
           <a:p>
             <a:r>
-              <a:t>?</a:t>
+              <a:t>5</a:t>
             </a:r>
           </a:p>
         </p:txBody>
@@ -14419,7 +14419,7 @@
           <a:lstStyle/>
           <a:p>
             <a:r>
-              <a:t>Performance recorded?</a:t>
+              <a:t>Performance observed</a:t>
             </a:r>
           </a:p>
         </p:txBody>
@@ -14490,7 +14490,7 @@
           <a:lstStyle/>
           <a:p>
             <a:r>
-              <a:t>90 not shortlisted: no hire decision  |  9 shortlisted, not hired  |  up to 99 performance outcomes missing if only the hire is assessed</a:t>
+              <a:t>40 not shortlisted: no hire decision  |  5 shortlisted, not hired  |  45 performance scores missing</a:t>
             </a:r>
           </a:p>
         </p:txBody>
@@ -14518,7 +14518,7 @@
           <a:lstStyle/>
           <a:p>
             <a:r>
-              <a:t>Hire status is not performance. Keep unknown outcomes missing.</a:t>
+              <a:t>Missing hire/performance outcomes are unknown, not negative.</a:t>
             </a:r>
           </a:p>
         </p:txBody>

</xml_diff>